<commit_message>
Audit three papers, and say which pair is the controlled one
The archived paper is on SGC/Cora; the gated run is on data efficiency. Setting
those two side by side would compare a gate against a topic change, and any
difference could be read either way.

So the table now has three rows. The first two are the real ablation: same
research question, same engineer model, same prompts, GATES_GATE1=off on one
side -- the gate is the only variable. The third is the archived run, kept
because a controlled pair shows what the gate changes while an independent
instance shows the failure was not manufactured for the occasion. The slide and
the section both say which is which, since a reader who assumes all three are
comparable would draw a stronger conclusion than the evidence supports.

Rows for runs still in flight read "paper not found" rather than rendering as
zero.
</commit_message>
<xml_diff>
--- a/reports/GATE1_DECK.pptx
+++ b/reports/GATE1_DECK.pptx
@@ -5787,7 +5787,7 @@
         </p:nvGraphicFramePr>
         <p:xfrm>
           <a:off x="548640" y="1600200"/>
-          <a:ext cx="11064240" cy="1371600"/>
+          <a:ext cx="11064240" cy="1828800"/>
         </p:xfrm>
         <a:graphic>
           <a:graphicData uri="http://schemas.openxmlformats.org/drawingml/2006/table">
@@ -5796,10 +5796,10 @@
                 <a:tableStyleId>{5C22544A-7EE6-4342-B048-85BDC9FD1C3A}</a:tableStyleId>
               </a:tblPr>
               <a:tblGrid>
-                <a:gridCol w="3291840"/>
-                <a:gridCol w="2743200"/>
-                <a:gridCol w="2743200"/>
-                <a:gridCol w="2286000"/>
+                <a:gridCol w="4206240"/>
+                <a:gridCol w="2377440"/>
+                <a:gridCol w="2468880"/>
+                <a:gridCol w="2011680"/>
               </a:tblGrid>
               <a:tr h="457200">
                 <a:tc>
@@ -5808,7 +5808,7 @@
                     <a:lstStyle/>
                     <a:p>
                       <a:pPr>
-                        <a:defRPr sz="1300" b="1">
+                        <a:defRPr sz="1200" b="1">
                           <a:solidFill>
                             <a:srgbClr val="0B0B0B"/>
                           </a:solidFill>
@@ -5832,7 +5832,7 @@
                     <a:lstStyle/>
                     <a:p>
                       <a:pPr>
-                        <a:defRPr sz="1300" b="1">
+                        <a:defRPr sz="1200" b="1">
                           <a:solidFill>
                             <a:srgbClr val="0B0B0B"/>
                           </a:solidFill>
@@ -5856,7 +5856,7 @@
                     <a:lstStyle/>
                     <a:p>
                       <a:pPr>
-                        <a:defRPr sz="1300" b="1">
+                        <a:defRPr sz="1200" b="1">
                           <a:solidFill>
                             <a:srgbClr val="0B0B0B"/>
                           </a:solidFill>
@@ -5880,7 +5880,7 @@
                     <a:lstStyle/>
                     <a:p>
                       <a:pPr>
-                        <a:defRPr sz="1300" b="1">
+                        <a:defRPr sz="1200" b="1">
                           <a:solidFill>
                             <a:srgbClr val="0B0B0B"/>
                           </a:solidFill>
@@ -5906,7 +5906,105 @@
                     <a:lstStyle/>
                     <a:p>
                       <a:pPr>
-                        <a:defRPr sz="1300" b="0">
+                        <a:defRPr sz="1200" b="0">
+                          <a:solidFill>
+                            <a:srgbClr val="52514E"/>
+                          </a:solidFill>
+                          <a:latin typeface="DejaVu Sans"/>
+                        </a:defRPr>
+                      </a:pPr>
+                      <a:r>
+                        <a:t>with Gate 1</a:t>
+                      </a:r>
+                    </a:p>
+                  </a:txBody>
+                  <a:tcPr>
+                    <a:solidFill>
+                      <a:srgbClr val="FCFCFB"/>
+                    </a:solidFill>
+                  </a:tcPr>
+                </a:tc>
+                <a:tc>
+                  <a:txBody>
+                    <a:bodyPr/>
+                    <a:lstStyle/>
+                    <a:p>
+                      <a:pPr>
+                        <a:defRPr sz="1200" b="0">
+                          <a:solidFill>
+                            <a:srgbClr val="52514E"/>
+                          </a:solidFill>
+                          <a:latin typeface="DejaVu Sans"/>
+                        </a:defRPr>
+                      </a:pPr>
+                      <a:r>
+                        <a:t>paper not found</a:t>
+                      </a:r>
+                    </a:p>
+                  </a:txBody>
+                  <a:tcPr>
+                    <a:solidFill>
+                      <a:srgbClr val="FCFCFB"/>
+                    </a:solidFill>
+                  </a:tcPr>
+                </a:tc>
+                <a:tc>
+                  <a:txBody>
+                    <a:bodyPr/>
+                    <a:lstStyle/>
+                    <a:p>
+                      <a:pPr>
+                        <a:defRPr sz="1200" b="0">
+                          <a:solidFill>
+                            <a:srgbClr val="52514E"/>
+                          </a:solidFill>
+                          <a:latin typeface="DejaVu Sans"/>
+                        </a:defRPr>
+                      </a:pPr>
+                      <a:r>
+                        <a:t>—</a:t>
+                      </a:r>
+                    </a:p>
+                  </a:txBody>
+                  <a:tcPr>
+                    <a:solidFill>
+                      <a:srgbClr val="FCFCFB"/>
+                    </a:solidFill>
+                  </a:tcPr>
+                </a:tc>
+                <a:tc>
+                  <a:txBody>
+                    <a:bodyPr/>
+                    <a:lstStyle/>
+                    <a:p>
+                      <a:pPr>
+                        <a:defRPr sz="1200" b="0">
+                          <a:solidFill>
+                            <a:srgbClr val="52514E"/>
+                          </a:solidFill>
+                          <a:latin typeface="DejaVu Sans"/>
+                        </a:defRPr>
+                      </a:pPr>
+                      <a:r>
+                        <a:t>—</a:t>
+                      </a:r>
+                    </a:p>
+                  </a:txBody>
+                  <a:tcPr>
+                    <a:solidFill>
+                      <a:srgbClr val="FCFCFB"/>
+                    </a:solidFill>
+                  </a:tcPr>
+                </a:tc>
+              </a:tr>
+              <a:tr h="457200">
+                <a:tc>
+                  <a:txBody>
+                    <a:bodyPr/>
+                    <a:lstStyle/>
+                    <a:p>
+                      <a:pPr>
+                        <a:defRPr sz="1200" b="0">
                           <a:solidFill>
                             <a:srgbClr val="52514E"/>
                           </a:solidFill>
@@ -5930,7 +6028,105 @@
                     <a:lstStyle/>
                     <a:p>
                       <a:pPr>
-                        <a:defRPr sz="1300" b="0">
+                        <a:defRPr sz="1200" b="0">
+                          <a:solidFill>
+                            <a:srgbClr val="52514E"/>
+                          </a:solidFill>
+                          <a:latin typeface="DejaVu Sans"/>
+                        </a:defRPr>
+                      </a:pPr>
+                      <a:r>
+                        <a:t>paper not found</a:t>
+                      </a:r>
+                    </a:p>
+                  </a:txBody>
+                  <a:tcPr>
+                    <a:solidFill>
+                      <a:srgbClr val="FCFCFB"/>
+                    </a:solidFill>
+                  </a:tcPr>
+                </a:tc>
+                <a:tc>
+                  <a:txBody>
+                    <a:bodyPr/>
+                    <a:lstStyle/>
+                    <a:p>
+                      <a:pPr>
+                        <a:defRPr sz="1200" b="0">
+                          <a:solidFill>
+                            <a:srgbClr val="52514E"/>
+                          </a:solidFill>
+                          <a:latin typeface="DejaVu Sans"/>
+                        </a:defRPr>
+                      </a:pPr>
+                      <a:r>
+                        <a:t>—</a:t>
+                      </a:r>
+                    </a:p>
+                  </a:txBody>
+                  <a:tcPr>
+                    <a:solidFill>
+                      <a:srgbClr val="FCFCFB"/>
+                    </a:solidFill>
+                  </a:tcPr>
+                </a:tc>
+                <a:tc>
+                  <a:txBody>
+                    <a:bodyPr/>
+                    <a:lstStyle/>
+                    <a:p>
+                      <a:pPr>
+                        <a:defRPr sz="1200" b="0">
+                          <a:solidFill>
+                            <a:srgbClr val="52514E"/>
+                          </a:solidFill>
+                          <a:latin typeface="DejaVu Sans"/>
+                        </a:defRPr>
+                      </a:pPr>
+                      <a:r>
+                        <a:t>—</a:t>
+                      </a:r>
+                    </a:p>
+                  </a:txBody>
+                  <a:tcPr>
+                    <a:solidFill>
+                      <a:srgbClr val="FCFCFB"/>
+                    </a:solidFill>
+                  </a:tcPr>
+                </a:tc>
+              </a:tr>
+              <a:tr h="457200">
+                <a:tc>
+                  <a:txBody>
+                    <a:bodyPr/>
+                    <a:lstStyle/>
+                    <a:p>
+                      <a:pPr>
+                        <a:defRPr sz="1200" b="0">
+                          <a:solidFill>
+                            <a:srgbClr val="52514E"/>
+                          </a:solidFill>
+                          <a:latin typeface="DejaVu Sans"/>
+                        </a:defRPr>
+                      </a:pPr>
+                      <a:r>
+                        <a:t>archived run (different topic, no gate)</a:t>
+                      </a:r>
+                    </a:p>
+                  </a:txBody>
+                  <a:tcPr>
+                    <a:solidFill>
+                      <a:srgbClr val="FCFCFB"/>
+                    </a:solidFill>
+                  </a:tcPr>
+                </a:tc>
+                <a:tc>
+                  <a:txBody>
+                    <a:bodyPr/>
+                    <a:lstStyle/>
+                    <a:p>
+                      <a:pPr>
+                        <a:defRPr sz="1200" b="0">
                           <a:solidFill>
                             <a:srgbClr val="52514E"/>
                           </a:solidFill>
@@ -5954,7 +6150,7 @@
                     <a:lstStyle/>
                     <a:p>
                       <a:pPr>
-                        <a:defRPr sz="1300" b="0">
+                        <a:defRPr sz="1200" b="0">
                           <a:solidFill>
                             <a:srgbClr val="52514E"/>
                           </a:solidFill>
@@ -5978,7 +6174,7 @@
                     <a:lstStyle/>
                     <a:p>
                       <a:pPr>
-                        <a:defRPr sz="1300" b="0">
+                        <a:defRPr sz="1200" b="0">
                           <a:solidFill>
                             <a:srgbClr val="52514E"/>
                           </a:solidFill>
@@ -5997,104 +6193,6 @@
                   </a:tcPr>
                 </a:tc>
               </a:tr>
-              <a:tr h="457200">
-                <a:tc>
-                  <a:txBody>
-                    <a:bodyPr/>
-                    <a:lstStyle/>
-                    <a:p>
-                      <a:pPr>
-                        <a:defRPr sz="1300" b="0">
-                          <a:solidFill>
-                            <a:srgbClr val="52514E"/>
-                          </a:solidFill>
-                          <a:latin typeface="DejaVu Sans"/>
-                        </a:defRPr>
-                      </a:pPr>
-                      <a:r>
-                        <a:t>with Gate 1</a:t>
-                      </a:r>
-                    </a:p>
-                  </a:txBody>
-                  <a:tcPr>
-                    <a:solidFill>
-                      <a:srgbClr val="FCFCFB"/>
-                    </a:solidFill>
-                  </a:tcPr>
-                </a:tc>
-                <a:tc>
-                  <a:txBody>
-                    <a:bodyPr/>
-                    <a:lstStyle/>
-                    <a:p>
-                      <a:pPr>
-                        <a:defRPr sz="1300" b="0">
-                          <a:solidFill>
-                            <a:srgbClr val="52514E"/>
-                          </a:solidFill>
-                          <a:latin typeface="DejaVu Sans"/>
-                        </a:defRPr>
-                      </a:pPr>
-                      <a:r>
-                        <a:t>paper not found</a:t>
-                      </a:r>
-                    </a:p>
-                  </a:txBody>
-                  <a:tcPr>
-                    <a:solidFill>
-                      <a:srgbClr val="FCFCFB"/>
-                    </a:solidFill>
-                  </a:tcPr>
-                </a:tc>
-                <a:tc>
-                  <a:txBody>
-                    <a:bodyPr/>
-                    <a:lstStyle/>
-                    <a:p>
-                      <a:pPr>
-                        <a:defRPr sz="1300" b="0">
-                          <a:solidFill>
-                            <a:srgbClr val="52514E"/>
-                          </a:solidFill>
-                          <a:latin typeface="DejaVu Sans"/>
-                        </a:defRPr>
-                      </a:pPr>
-                      <a:r>
-                        <a:t>—</a:t>
-                      </a:r>
-                    </a:p>
-                  </a:txBody>
-                  <a:tcPr>
-                    <a:solidFill>
-                      <a:srgbClr val="FCFCFB"/>
-                    </a:solidFill>
-                  </a:tcPr>
-                </a:tc>
-                <a:tc>
-                  <a:txBody>
-                    <a:bodyPr/>
-                    <a:lstStyle/>
-                    <a:p>
-                      <a:pPr>
-                        <a:defRPr sz="1300" b="0">
-                          <a:solidFill>
-                            <a:srgbClr val="52514E"/>
-                          </a:solidFill>
-                          <a:latin typeface="DejaVu Sans"/>
-                        </a:defRPr>
-                      </a:pPr>
-                      <a:r>
-                        <a:t>—</a:t>
-                      </a:r>
-                    </a:p>
-                  </a:txBody>
-                  <a:tcPr>
-                    <a:solidFill>
-                      <a:srgbClr val="FCFCFB"/>
-                    </a:solidFill>
-                  </a:tcPr>
-                </a:tc>
-              </a:tr>
             </a:tbl>
           </a:graphicData>
         </a:graphic>
@@ -6107,8 +6205,8 @@
         </p:nvSpPr>
         <p:spPr>
           <a:xfrm>
-            <a:off x="548640" y="3840480"/>
-            <a:ext cx="11064240" cy="2194560"/>
+            <a:off x="548640" y="3703320"/>
+            <a:ext cx="11064240" cy="2377440"/>
           </a:xfrm>
           <a:prstGeom prst="rect">
             <a:avLst/>
@@ -6127,13 +6225,13 @@
               </a:lnSpc>
             </a:pPr>
             <a:r>
-              <a:rPr sz="1500" b="1">
+              <a:rPr sz="1300" b="1">
                 <a:solidFill>
                   <a:srgbClr val="0B0B0B"/>
                 </a:solidFill>
                 <a:latin typeface="DejaVu Sans"/>
               </a:rPr>
-              <a:t>The archived paper reads well. That is the problem.</a:t>
+              <a:t>The first two rows are the ablation: same question, same model, same prompts — the gate is the only difference.</a:t>
             </a:r>
           </a:p>
           <a:p>
@@ -6143,13 +6241,13 @@
               </a:lnSpc>
             </a:pPr>
             <a:r>
-              <a:rPr sz="1300" b="0">
+              <a:rPr sz="1200" b="0">
                 <a:solidFill>
                   <a:srgbClr val="52514E"/>
                 </a:solidFill>
                 <a:latin typeface="DejaVu Sans"/>
               </a:rPr>
-              <a:t>It states 65 numeric findings and sources none of them: 81.60% test accuracy, a 13.61x speedup, a 39.20% collapse. Its saved code calls record_result zero times and contains none of those numbers. The run behind it raised NameError on every attempt and scored 1.0.</a:t>
+              <a:t>The third is the archived Agent Laboratory run on its own topic. One controlled pair shows what the gate changes; an independent instance shows the failure was not manufactured for the occasion.</a:t>
             </a:r>
           </a:p>
           <a:p>
@@ -6159,13 +6257,45 @@
               </a:lnSpc>
             </a:pPr>
             <a:r>
-              <a:rPr sz="1300" b="0">
-                <a:solidFill>
-                  <a:srgbClr val="EB6834"/>
+              <a:rPr sz="800" b="0">
+                <a:solidFill>
+                  <a:srgbClr val="52514E"/>
                 </a:solidFill>
                 <a:latin typeface="DejaVu Sans"/>
               </a:rPr>
-              <a:t>Nothing in the pipeline could tell the difference between a measurement and a sentence. That is what a validity layer is for.</a:t>
+              <a:t/>
+            </a:r>
+          </a:p>
+          <a:p>
+            <a:pPr algn="l">
+              <a:lnSpc>
+                <a:spcPct val="115000"/>
+              </a:lnSpc>
+            </a:pPr>
+            <a:r>
+              <a:rPr sz="1200" b="0">
+                <a:solidFill>
+                  <a:srgbClr val="52514E"/>
+                </a:solidFill>
+                <a:latin typeface="DejaVu Sans"/>
+              </a:rPr>
+              <a:t>That archived paper states 65 numeric findings and sources none of them: 81.60% test accuracy, a 13.61x speedup, a 39.20% collapse. Its saved code calls record_result zero times and contains none of those numbers. The run behind it raised NameError on every attempt and scored 1.0.</a:t>
+            </a:r>
+          </a:p>
+          <a:p>
+            <a:pPr algn="l">
+              <a:lnSpc>
+                <a:spcPct val="115000"/>
+              </a:lnSpc>
+            </a:pPr>
+            <a:r>
+              <a:rPr sz="1300" b="1">
+                <a:solidFill>
+                  <a:srgbClr val="EB6834"/>
+                </a:solidFill>
+                <a:latin typeface="DejaVu Sans"/>
+              </a:rPr>
+              <a:t>Nothing in the pipeline could tell the difference between a measurement and a sentence.</a:t>
             </a:r>
           </a:p>
         </p:txBody>
@@ -6614,7 +6744,7 @@
         </p:nvGraphicFramePr>
         <p:xfrm>
           <a:off x="548640" y="1554480"/>
-          <a:ext cx="11064240" cy="2414016"/>
+          <a:ext cx="11064240" cy="2816352"/>
         </p:xfrm>
         <a:graphic>
           <a:graphicData uri="http://schemas.openxmlformats.org/drawingml/2006/table">
@@ -7216,6 +7346,104 @@
                   </a:tcPr>
                 </a:tc>
               </a:tr>
+              <a:tr h="402336">
+                <a:tc>
+                  <a:txBody>
+                    <a:bodyPr/>
+                    <a:lstStyle/>
+                    <a:p>
+                      <a:pPr>
+                        <a:defRPr sz="1200" b="0">
+                          <a:solidFill>
+                            <a:srgbClr val="52514E"/>
+                          </a:solidFill>
+                          <a:latin typeface="DejaVu Sans"/>
+                        </a:defRPr>
+                      </a:pPr>
+                      <a:r>
+                        <a:t>attempt 07</a:t>
+                      </a:r>
+                    </a:p>
+                  </a:txBody>
+                  <a:tcPr>
+                    <a:solidFill>
+                      <a:srgbClr val="FCFCFB"/>
+                    </a:solidFill>
+                  </a:tcPr>
+                </a:tc>
+                <a:tc>
+                  <a:txBody>
+                    <a:bodyPr/>
+                    <a:lstStyle/>
+                    <a:p>
+                      <a:pPr>
+                        <a:defRPr sz="1200" b="0">
+                          <a:solidFill>
+                            <a:srgbClr val="52514E"/>
+                          </a:solidFill>
+                          <a:latin typeface="DejaVu Sans"/>
+                        </a:defRPr>
+                      </a:pPr>
+                      <a:r>
+                        <a:t>PASS</a:t>
+                      </a:r>
+                    </a:p>
+                  </a:txBody>
+                  <a:tcPr>
+                    <a:solidFill>
+                      <a:srgbClr val="FCFCFB"/>
+                    </a:solidFill>
+                  </a:tcPr>
+                </a:tc>
+                <a:tc>
+                  <a:txBody>
+                    <a:bodyPr/>
+                    <a:lstStyle/>
+                    <a:p>
+                      <a:pPr>
+                        <a:defRPr sz="1200" b="0">
+                          <a:solidFill>
+                            <a:srgbClr val="52514E"/>
+                          </a:solidFill>
+                          <a:latin typeface="DejaVu Sans"/>
+                        </a:defRPr>
+                      </a:pPr>
+                      <a:r>
+                        <a:t>12</a:t>
+                      </a:r>
+                    </a:p>
+                  </a:txBody>
+                  <a:tcPr>
+                    <a:solidFill>
+                      <a:srgbClr val="FCFCFB"/>
+                    </a:solidFill>
+                  </a:tcPr>
+                </a:tc>
+                <a:tc>
+                  <a:txBody>
+                    <a:bodyPr/>
+                    <a:lstStyle/>
+                    <a:p>
+                      <a:pPr>
+                        <a:defRPr sz="1200" b="0">
+                          <a:solidFill>
+                            <a:srgbClr val="52514E"/>
+                          </a:solidFill>
+                          <a:latin typeface="DejaVu Sans"/>
+                        </a:defRPr>
+                      </a:pPr>
+                      <a:r>
+                        <a:t>—</a:t>
+                      </a:r>
+                    </a:p>
+                  </a:txBody>
+                  <a:tcPr>
+                    <a:solidFill>
+                      <a:srgbClr val="FCFCFB"/>
+                    </a:solidFill>
+                  </a:tcPr>
+                </a:tc>
+              </a:tr>
             </a:tbl>
           </a:graphicData>
         </a:graphic>
@@ -7228,7 +7456,7 @@
         </p:nvSpPr>
         <p:spPr>
           <a:xfrm>
-            <a:off x="548640" y="4334256"/>
+            <a:off x="548640" y="4736592"/>
             <a:ext cx="11064240" cy="1828800"/>
           </a:xfrm>
           <a:prstGeom prst="rect">

</xml_diff>